<commit_message>
Candidacy Done. All materials and feedback added
</commit_message>
<xml_diff>
--- a/ppts/figs.pptx
+++ b/ppts/figs.pptx
@@ -6,7 +6,9 @@
   </p:sldMasterIdLst>
   <p:sldIdLst>
     <p:sldId id="256" r:id="rId2"/>
-    <p:sldId id="257" r:id="rId3"/>
+    <p:sldId id="258" r:id="rId3"/>
+    <p:sldId id="257" r:id="rId4"/>
+    <p:sldId id="259" r:id="rId5"/>
   </p:sldIdLst>
   <p:sldSz cx="12192000" cy="6858000"/>
   <p:notesSz cx="6858000" cy="9144000"/>
@@ -260,7 +262,7 @@
           <a:p>
             <a:fld id="{B5CA1BEC-2BF3-E549-B749-A0163A5C48C8}" type="datetimeFigureOut">
               <a:rPr lang="en-US" smtClean="0"/>
-              <a:t>7/2/24</a:t>
+              <a:t>7/9/24</a:t>
             </a:fld>
             <a:endParaRPr lang="en-US"/>
           </a:p>
@@ -458,7 +460,7 @@
           <a:p>
             <a:fld id="{B5CA1BEC-2BF3-E549-B749-A0163A5C48C8}" type="datetimeFigureOut">
               <a:rPr lang="en-US" smtClean="0"/>
-              <a:t>7/2/24</a:t>
+              <a:t>7/9/24</a:t>
             </a:fld>
             <a:endParaRPr lang="en-US"/>
           </a:p>
@@ -666,7 +668,7 @@
           <a:p>
             <a:fld id="{B5CA1BEC-2BF3-E549-B749-A0163A5C48C8}" type="datetimeFigureOut">
               <a:rPr lang="en-US" smtClean="0"/>
-              <a:t>7/2/24</a:t>
+              <a:t>7/9/24</a:t>
             </a:fld>
             <a:endParaRPr lang="en-US"/>
           </a:p>
@@ -864,7 +866,7 @@
           <a:p>
             <a:fld id="{B5CA1BEC-2BF3-E549-B749-A0163A5C48C8}" type="datetimeFigureOut">
               <a:rPr lang="en-US" smtClean="0"/>
-              <a:t>7/2/24</a:t>
+              <a:t>7/9/24</a:t>
             </a:fld>
             <a:endParaRPr lang="en-US"/>
           </a:p>
@@ -1139,7 +1141,7 @@
           <a:p>
             <a:fld id="{B5CA1BEC-2BF3-E549-B749-A0163A5C48C8}" type="datetimeFigureOut">
               <a:rPr lang="en-US" smtClean="0"/>
-              <a:t>7/2/24</a:t>
+              <a:t>7/9/24</a:t>
             </a:fld>
             <a:endParaRPr lang="en-US"/>
           </a:p>
@@ -1404,7 +1406,7 @@
           <a:p>
             <a:fld id="{B5CA1BEC-2BF3-E549-B749-A0163A5C48C8}" type="datetimeFigureOut">
               <a:rPr lang="en-US" smtClean="0"/>
-              <a:t>7/2/24</a:t>
+              <a:t>7/9/24</a:t>
             </a:fld>
             <a:endParaRPr lang="en-US"/>
           </a:p>
@@ -1816,7 +1818,7 @@
           <a:p>
             <a:fld id="{B5CA1BEC-2BF3-E549-B749-A0163A5C48C8}" type="datetimeFigureOut">
               <a:rPr lang="en-US" smtClean="0"/>
-              <a:t>7/2/24</a:t>
+              <a:t>7/9/24</a:t>
             </a:fld>
             <a:endParaRPr lang="en-US"/>
           </a:p>
@@ -1957,7 +1959,7 @@
           <a:p>
             <a:fld id="{B5CA1BEC-2BF3-E549-B749-A0163A5C48C8}" type="datetimeFigureOut">
               <a:rPr lang="en-US" smtClean="0"/>
-              <a:t>7/2/24</a:t>
+              <a:t>7/9/24</a:t>
             </a:fld>
             <a:endParaRPr lang="en-US"/>
           </a:p>
@@ -2070,7 +2072,7 @@
           <a:p>
             <a:fld id="{B5CA1BEC-2BF3-E549-B749-A0163A5C48C8}" type="datetimeFigureOut">
               <a:rPr lang="en-US" smtClean="0"/>
-              <a:t>7/2/24</a:t>
+              <a:t>7/9/24</a:t>
             </a:fld>
             <a:endParaRPr lang="en-US"/>
           </a:p>
@@ -2381,7 +2383,7 @@
           <a:p>
             <a:fld id="{B5CA1BEC-2BF3-E549-B749-A0163A5C48C8}" type="datetimeFigureOut">
               <a:rPr lang="en-US" smtClean="0"/>
-              <a:t>7/2/24</a:t>
+              <a:t>7/9/24</a:t>
             </a:fld>
             <a:endParaRPr lang="en-US"/>
           </a:p>
@@ -2669,7 +2671,7 @@
           <a:p>
             <a:fld id="{B5CA1BEC-2BF3-E549-B749-A0163A5C48C8}" type="datetimeFigureOut">
               <a:rPr lang="en-US" smtClean="0"/>
-              <a:t>7/2/24</a:t>
+              <a:t>7/9/24</a:t>
             </a:fld>
             <a:endParaRPr lang="en-US"/>
           </a:p>
@@ -2910,7 +2912,7 @@
           <a:p>
             <a:fld id="{B5CA1BEC-2BF3-E549-B749-A0163A5C48C8}" type="datetimeFigureOut">
               <a:rPr lang="en-US" smtClean="0"/>
-              <a:t>7/2/24</a:t>
+              <a:t>7/9/24</a:t>
             </a:fld>
             <a:endParaRPr lang="en-US"/>
           </a:p>
@@ -4389,14 +4391,14 @@
             <a:lstStyle/>
             <a:p>
               <a:r>
-                <a:rPr lang="en-US" sz="1400" dirty="0" err="1">
+                <a:rPr lang="en-US" sz="1400" dirty="0">
                   <a:latin typeface="Arial" panose="020B0604020202020204" pitchFamily="34" charset="0"/>
                   <a:cs typeface="Arial" panose="020B0604020202020204" pitchFamily="34" charset="0"/>
                 </a:rPr>
                 <a:t>Thread</a:t>
               </a:r>
               <a:r>
-                <a:rPr lang="en-US" sz="1400" baseline="-25000" dirty="0" err="1">
+                <a:rPr lang="en-US" sz="1400" baseline="-25000" dirty="0">
                   <a:latin typeface="Arial" panose="020B0604020202020204" pitchFamily="34" charset="0"/>
                   <a:cs typeface="Arial" panose="020B0604020202020204" pitchFamily="34" charset="0"/>
                 </a:rPr>
@@ -4424,6 +4426,1119 @@
 </file>
 
 <file path=ppt/slides/slide2.xml><?xml version="1.0" encoding="utf-8"?>
+<p:sld xmlns:a="http://schemas.openxmlformats.org/drawingml/2006/main" xmlns:r="http://schemas.openxmlformats.org/officeDocument/2006/relationships" xmlns:p="http://schemas.openxmlformats.org/presentationml/2006/main">
+  <p:cSld>
+    <p:spTree>
+      <p:nvGrpSpPr>
+        <p:cNvPr id="1" name=""/>
+        <p:cNvGrpSpPr/>
+        <p:nvPr/>
+      </p:nvGrpSpPr>
+      <p:grpSpPr>
+        <a:xfrm>
+          <a:off x="0" y="0"/>
+          <a:ext cx="0" cy="0"/>
+          <a:chOff x="0" y="0"/>
+          <a:chExt cx="0" cy="0"/>
+        </a:xfrm>
+      </p:grpSpPr>
+      <p:grpSp>
+        <p:nvGrpSpPr>
+          <p:cNvPr id="2" name="Group 1">
+            <a:extLst>
+              <a:ext uri="{FF2B5EF4-FFF2-40B4-BE49-F238E27FC236}">
+                <a16:creationId xmlns:a16="http://schemas.microsoft.com/office/drawing/2014/main" id="{56690775-484B-475E-B9C3-FA89BEF48E81}"/>
+              </a:ext>
+            </a:extLst>
+          </p:cNvPr>
+          <p:cNvGrpSpPr/>
+          <p:nvPr/>
+        </p:nvGrpSpPr>
+        <p:grpSpPr>
+          <a:xfrm>
+            <a:off x="2532756" y="2510288"/>
+            <a:ext cx="7404874" cy="2468112"/>
+            <a:chOff x="2532756" y="2510288"/>
+            <a:chExt cx="7404874" cy="2468112"/>
+          </a:xfrm>
+        </p:grpSpPr>
+        <p:sp>
+          <p:nvSpPr>
+            <p:cNvPr id="3" name="Rectangle 2">
+              <a:extLst>
+                <a:ext uri="{FF2B5EF4-FFF2-40B4-BE49-F238E27FC236}">
+                  <a16:creationId xmlns:a16="http://schemas.microsoft.com/office/drawing/2014/main" id="{5E3F2170-0B93-3242-5AC4-E13B6B3FE77E}"/>
+                </a:ext>
+              </a:extLst>
+            </p:cNvPr>
+            <p:cNvSpPr/>
+            <p:nvPr/>
+          </p:nvSpPr>
+          <p:spPr>
+            <a:xfrm>
+              <a:off x="2540000" y="2510288"/>
+              <a:ext cx="7397630" cy="2468112"/>
+            </a:xfrm>
+            <a:prstGeom prst="rect">
+              <a:avLst/>
+            </a:prstGeom>
+            <a:noFill/>
+          </p:spPr>
+          <p:style>
+            <a:lnRef idx="2">
+              <a:schemeClr val="accent1">
+                <a:shade val="15000"/>
+              </a:schemeClr>
+            </a:lnRef>
+            <a:fillRef idx="1">
+              <a:schemeClr val="accent1"/>
+            </a:fillRef>
+            <a:effectRef idx="0">
+              <a:schemeClr val="accent1"/>
+            </a:effectRef>
+            <a:fontRef idx="minor">
+              <a:schemeClr val="lt1"/>
+            </a:fontRef>
+          </p:style>
+          <p:txBody>
+            <a:bodyPr rtlCol="0" anchor="ctr"/>
+            <a:lstStyle/>
+            <a:p>
+              <a:pPr algn="ctr"/>
+              <a:endParaRPr lang="en-US" sz="1600">
+                <a:latin typeface="Arial" panose="020B0604020202020204" pitchFamily="34" charset="0"/>
+                <a:cs typeface="Arial" panose="020B0604020202020204" pitchFamily="34" charset="0"/>
+              </a:endParaRPr>
+            </a:p>
+          </p:txBody>
+        </p:sp>
+        <p:sp>
+          <p:nvSpPr>
+            <p:cNvPr id="4" name="TextBox 3">
+              <a:extLst>
+                <a:ext uri="{FF2B5EF4-FFF2-40B4-BE49-F238E27FC236}">
+                  <a16:creationId xmlns:a16="http://schemas.microsoft.com/office/drawing/2014/main" id="{E67590A0-3CD0-6123-9DA8-37E3C3081A6F}"/>
+                </a:ext>
+              </a:extLst>
+            </p:cNvPr>
+            <p:cNvSpPr txBox="1"/>
+            <p:nvPr/>
+          </p:nvSpPr>
+          <p:spPr>
+            <a:xfrm>
+              <a:off x="5213317" y="4435789"/>
+              <a:ext cx="2050996" cy="498279"/>
+            </a:xfrm>
+            <a:prstGeom prst="rect">
+              <a:avLst/>
+            </a:prstGeom>
+          </p:spPr>
+          <p:style>
+            <a:lnRef idx="2">
+              <a:schemeClr val="accent1">
+                <a:shade val="15000"/>
+              </a:schemeClr>
+            </a:lnRef>
+            <a:fillRef idx="1">
+              <a:schemeClr val="accent1"/>
+            </a:fillRef>
+            <a:effectRef idx="0">
+              <a:schemeClr val="accent1"/>
+            </a:effectRef>
+            <a:fontRef idx="minor">
+              <a:schemeClr val="lt1"/>
+            </a:fontRef>
+          </p:style>
+          <p:txBody>
+            <a:bodyPr rtlCol="0" anchor="ctr"/>
+            <a:lstStyle>
+              <a:defPPr>
+                <a:defRPr lang="en-US"/>
+              </a:defPPr>
+              <a:lvl1pPr algn="ctr">
+                <a:defRPr>
+                  <a:solidFill>
+                    <a:schemeClr val="lt1"/>
+                  </a:solidFill>
+                </a:defRPr>
+              </a:lvl1pPr>
+              <a:lvl2pPr>
+                <a:defRPr>
+                  <a:solidFill>
+                    <a:schemeClr val="lt1"/>
+                  </a:solidFill>
+                </a:defRPr>
+              </a:lvl2pPr>
+              <a:lvl3pPr>
+                <a:defRPr>
+                  <a:solidFill>
+                    <a:schemeClr val="lt1"/>
+                  </a:solidFill>
+                </a:defRPr>
+              </a:lvl3pPr>
+              <a:lvl4pPr>
+                <a:defRPr>
+                  <a:solidFill>
+                    <a:schemeClr val="lt1"/>
+                  </a:solidFill>
+                </a:defRPr>
+              </a:lvl4pPr>
+              <a:lvl5pPr>
+                <a:defRPr>
+                  <a:solidFill>
+                    <a:schemeClr val="lt1"/>
+                  </a:solidFill>
+                </a:defRPr>
+              </a:lvl5pPr>
+              <a:lvl6pPr>
+                <a:defRPr>
+                  <a:solidFill>
+                    <a:schemeClr val="lt1"/>
+                  </a:solidFill>
+                </a:defRPr>
+              </a:lvl6pPr>
+              <a:lvl7pPr>
+                <a:defRPr>
+                  <a:solidFill>
+                    <a:schemeClr val="lt1"/>
+                  </a:solidFill>
+                </a:defRPr>
+              </a:lvl7pPr>
+              <a:lvl8pPr>
+                <a:defRPr>
+                  <a:solidFill>
+                    <a:schemeClr val="lt1"/>
+                  </a:solidFill>
+                </a:defRPr>
+              </a:lvl8pPr>
+              <a:lvl9pPr>
+                <a:defRPr>
+                  <a:solidFill>
+                    <a:schemeClr val="lt1"/>
+                  </a:solidFill>
+                </a:defRPr>
+              </a:lvl9pPr>
+            </a:lstStyle>
+            <a:p>
+              <a:r>
+                <a:rPr lang="en-US" sz="1600" dirty="0">
+                  <a:latin typeface="Arial" panose="020B0604020202020204" pitchFamily="34" charset="0"/>
+                  <a:cs typeface="Arial" panose="020B0604020202020204" pitchFamily="34" charset="0"/>
+                </a:rPr>
+                <a:t>GraphEngine</a:t>
+              </a:r>
+            </a:p>
+          </p:txBody>
+        </p:sp>
+        <p:cxnSp>
+          <p:nvCxnSpPr>
+            <p:cNvPr id="5" name="Straight Arrow Connector 4">
+              <a:extLst>
+                <a:ext uri="{FF2B5EF4-FFF2-40B4-BE49-F238E27FC236}">
+                  <a16:creationId xmlns:a16="http://schemas.microsoft.com/office/drawing/2014/main" id="{EFBC507B-693F-713C-08B2-2CAFFF11B25E}"/>
+                </a:ext>
+              </a:extLst>
+            </p:cNvPr>
+            <p:cNvCxnSpPr>
+              <a:cxnSpLocks/>
+              <a:stCxn id="4" idx="0"/>
+              <a:endCxn id="20" idx="1"/>
+            </p:cNvCxnSpPr>
+            <p:nvPr/>
+          </p:nvCxnSpPr>
+          <p:spPr>
+            <a:xfrm flipV="1">
+              <a:off x="6238815" y="3885541"/>
+              <a:ext cx="1168925" cy="550248"/>
+            </a:xfrm>
+            <a:prstGeom prst="straightConnector1">
+              <a:avLst/>
+            </a:prstGeom>
+            <a:ln>
+              <a:tailEnd type="triangle"/>
+            </a:ln>
+          </p:spPr>
+          <p:style>
+            <a:lnRef idx="2">
+              <a:schemeClr val="accent1"/>
+            </a:lnRef>
+            <a:fillRef idx="0">
+              <a:schemeClr val="accent1"/>
+            </a:fillRef>
+            <a:effectRef idx="1">
+              <a:schemeClr val="accent1"/>
+            </a:effectRef>
+            <a:fontRef idx="minor">
+              <a:schemeClr val="tx1"/>
+            </a:fontRef>
+          </p:style>
+        </p:cxnSp>
+        <p:grpSp>
+          <p:nvGrpSpPr>
+            <p:cNvPr id="6" name="Group 5">
+              <a:extLst>
+                <a:ext uri="{FF2B5EF4-FFF2-40B4-BE49-F238E27FC236}">
+                  <a16:creationId xmlns:a16="http://schemas.microsoft.com/office/drawing/2014/main" id="{47D0E75B-CB71-A531-6D67-92CF047BE99F}"/>
+                </a:ext>
+              </a:extLst>
+            </p:cNvPr>
+            <p:cNvGrpSpPr/>
+            <p:nvPr/>
+          </p:nvGrpSpPr>
+          <p:grpSpPr>
+            <a:xfrm>
+              <a:off x="6613237" y="2570381"/>
+              <a:ext cx="3241090" cy="1712804"/>
+              <a:chOff x="6613237" y="2570381"/>
+              <a:chExt cx="3241090" cy="1712804"/>
+            </a:xfrm>
+          </p:grpSpPr>
+          <p:sp>
+            <p:nvSpPr>
+              <p:cNvPr id="19" name="Rectangle 18">
+                <a:extLst>
+                  <a:ext uri="{FF2B5EF4-FFF2-40B4-BE49-F238E27FC236}">
+                    <a16:creationId xmlns:a16="http://schemas.microsoft.com/office/drawing/2014/main" id="{CD9208FA-133C-F8CC-8901-E0B50C199DC8}"/>
+                  </a:ext>
+                </a:extLst>
+              </p:cNvPr>
+              <p:cNvSpPr/>
+              <p:nvPr/>
+            </p:nvSpPr>
+            <p:spPr>
+              <a:xfrm>
+                <a:off x="6613237" y="2570381"/>
+                <a:ext cx="3241090" cy="1712804"/>
+              </a:xfrm>
+              <a:prstGeom prst="rect">
+                <a:avLst/>
+              </a:prstGeom>
+              <a:solidFill>
+                <a:schemeClr val="accent1">
+                  <a:alpha val="25046"/>
+                </a:schemeClr>
+              </a:solidFill>
+            </p:spPr>
+            <p:style>
+              <a:lnRef idx="2">
+                <a:schemeClr val="accent1">
+                  <a:shade val="15000"/>
+                </a:schemeClr>
+              </a:lnRef>
+              <a:fillRef idx="1">
+                <a:schemeClr val="accent1"/>
+              </a:fillRef>
+              <a:effectRef idx="0">
+                <a:schemeClr val="accent1"/>
+              </a:effectRef>
+              <a:fontRef idx="minor">
+                <a:schemeClr val="lt1"/>
+              </a:fontRef>
+            </p:style>
+            <p:txBody>
+              <a:bodyPr rtlCol="0" anchor="ctr"/>
+              <a:lstStyle/>
+              <a:p>
+                <a:pPr algn="ctr"/>
+                <a:endParaRPr lang="en-US" sz="1600">
+                  <a:latin typeface="Arial" panose="020B0604020202020204" pitchFamily="34" charset="0"/>
+                  <a:cs typeface="Arial" panose="020B0604020202020204" pitchFamily="34" charset="0"/>
+                </a:endParaRPr>
+              </a:p>
+            </p:txBody>
+          </p:sp>
+          <p:sp>
+            <p:nvSpPr>
+              <p:cNvPr id="20" name="Rectangle 19">
+                <a:extLst>
+                  <a:ext uri="{FF2B5EF4-FFF2-40B4-BE49-F238E27FC236}">
+                    <a16:creationId xmlns:a16="http://schemas.microsoft.com/office/drawing/2014/main" id="{0D70CFE8-B10E-AB53-29D3-77E1E603C6D2}"/>
+                  </a:ext>
+                </a:extLst>
+              </p:cNvPr>
+              <p:cNvSpPr/>
+              <p:nvPr/>
+            </p:nvSpPr>
+            <p:spPr>
+              <a:xfrm>
+                <a:off x="7407740" y="3587789"/>
+                <a:ext cx="1643617" cy="595503"/>
+              </a:xfrm>
+              <a:prstGeom prst="rect">
+                <a:avLst/>
+              </a:prstGeom>
+            </p:spPr>
+            <p:style>
+              <a:lnRef idx="2">
+                <a:schemeClr val="accent1">
+                  <a:shade val="15000"/>
+                </a:schemeClr>
+              </a:lnRef>
+              <a:fillRef idx="1">
+                <a:schemeClr val="accent1"/>
+              </a:fillRef>
+              <a:effectRef idx="0">
+                <a:schemeClr val="accent1"/>
+              </a:effectRef>
+              <a:fontRef idx="minor">
+                <a:schemeClr val="lt1"/>
+              </a:fontRef>
+            </p:style>
+            <p:txBody>
+              <a:bodyPr rtlCol="0" anchor="ctr"/>
+              <a:lstStyle/>
+              <a:p>
+                <a:pPr algn="ctr"/>
+                <a:r>
+                  <a:rPr lang="en-US" sz="1600" dirty="0">
+                    <a:latin typeface="Arial" panose="020B0604020202020204" pitchFamily="34" charset="0"/>
+                    <a:cs typeface="Arial" panose="020B0604020202020204" pitchFamily="34" charset="0"/>
+                  </a:rPr>
+                  <a:t>GraphBase*</a:t>
+                </a:r>
+              </a:p>
+            </p:txBody>
+          </p:sp>
+          <p:sp>
+            <p:nvSpPr>
+              <p:cNvPr id="21" name="Rectangle 20">
+                <a:extLst>
+                  <a:ext uri="{FF2B5EF4-FFF2-40B4-BE49-F238E27FC236}">
+                    <a16:creationId xmlns:a16="http://schemas.microsoft.com/office/drawing/2014/main" id="{D223CC95-A6EC-FD07-01C3-AE033B486DA6}"/>
+                  </a:ext>
+                </a:extLst>
+              </p:cNvPr>
+              <p:cNvSpPr/>
+              <p:nvPr/>
+            </p:nvSpPr>
+            <p:spPr>
+              <a:xfrm>
+                <a:off x="6683801" y="2629453"/>
+                <a:ext cx="1521415" cy="595503"/>
+              </a:xfrm>
+              <a:prstGeom prst="rect">
+                <a:avLst/>
+              </a:prstGeom>
+            </p:spPr>
+            <p:style>
+              <a:lnRef idx="2">
+                <a:schemeClr val="accent1">
+                  <a:shade val="15000"/>
+                </a:schemeClr>
+              </a:lnRef>
+              <a:fillRef idx="1">
+                <a:schemeClr val="accent1"/>
+              </a:fillRef>
+              <a:effectRef idx="0">
+                <a:schemeClr val="accent1"/>
+              </a:effectRef>
+              <a:fontRef idx="minor">
+                <a:schemeClr val="lt1"/>
+              </a:fontRef>
+            </p:style>
+            <p:txBody>
+              <a:bodyPr rtlCol="0" anchor="ctr"/>
+              <a:lstStyle/>
+              <a:p>
+                <a:pPr algn="ctr"/>
+                <a:r>
+                  <a:rPr lang="en-US" sz="1600" dirty="0">
+                    <a:latin typeface="Arial" panose="020B0604020202020204" pitchFamily="34" charset="0"/>
+                    <a:cs typeface="Arial" panose="020B0604020202020204" pitchFamily="34" charset="0"/>
+                  </a:rPr>
+                  <a:t>NodeCursor*</a:t>
+                </a:r>
+              </a:p>
+            </p:txBody>
+          </p:sp>
+          <p:sp>
+            <p:nvSpPr>
+              <p:cNvPr id="22" name="Rectangle 21">
+                <a:extLst>
+                  <a:ext uri="{FF2B5EF4-FFF2-40B4-BE49-F238E27FC236}">
+                    <a16:creationId xmlns:a16="http://schemas.microsoft.com/office/drawing/2014/main" id="{CAEDFDBF-0DF3-C2FA-811B-8BC157206C01}"/>
+                  </a:ext>
+                </a:extLst>
+              </p:cNvPr>
+              <p:cNvSpPr/>
+              <p:nvPr/>
+            </p:nvSpPr>
+            <p:spPr>
+              <a:xfrm>
+                <a:off x="8249503" y="2635104"/>
+                <a:ext cx="1521415" cy="595503"/>
+              </a:xfrm>
+              <a:prstGeom prst="rect">
+                <a:avLst/>
+              </a:prstGeom>
+            </p:spPr>
+            <p:style>
+              <a:lnRef idx="2">
+                <a:schemeClr val="accent1">
+                  <a:shade val="15000"/>
+                </a:schemeClr>
+              </a:lnRef>
+              <a:fillRef idx="1">
+                <a:schemeClr val="accent1"/>
+              </a:fillRef>
+              <a:effectRef idx="0">
+                <a:schemeClr val="accent1"/>
+              </a:effectRef>
+              <a:fontRef idx="minor">
+                <a:schemeClr val="lt1"/>
+              </a:fontRef>
+            </p:style>
+            <p:txBody>
+              <a:bodyPr rtlCol="0" anchor="ctr"/>
+              <a:lstStyle/>
+              <a:p>
+                <a:pPr algn="ctr"/>
+                <a:r>
+                  <a:rPr lang="en-US" sz="1600" dirty="0">
+                    <a:latin typeface="Arial" panose="020B0604020202020204" pitchFamily="34" charset="0"/>
+                    <a:cs typeface="Arial" panose="020B0604020202020204" pitchFamily="34" charset="0"/>
+                  </a:rPr>
+                  <a:t>EdgeCursor*</a:t>
+                </a:r>
+              </a:p>
+            </p:txBody>
+          </p:sp>
+          <p:cxnSp>
+            <p:nvCxnSpPr>
+              <p:cNvPr id="23" name="Straight Arrow Connector 22">
+                <a:extLst>
+                  <a:ext uri="{FF2B5EF4-FFF2-40B4-BE49-F238E27FC236}">
+                    <a16:creationId xmlns:a16="http://schemas.microsoft.com/office/drawing/2014/main" id="{5F1F2E70-B55A-0347-7FF5-2D734D1DEA8B}"/>
+                  </a:ext>
+                </a:extLst>
+              </p:cNvPr>
+              <p:cNvCxnSpPr>
+                <a:cxnSpLocks/>
+                <a:stCxn id="20" idx="0"/>
+                <a:endCxn id="21" idx="2"/>
+              </p:cNvCxnSpPr>
+              <p:nvPr/>
+            </p:nvCxnSpPr>
+            <p:spPr>
+              <a:xfrm flipH="1" flipV="1">
+                <a:off x="7444509" y="3224956"/>
+                <a:ext cx="785040" cy="362833"/>
+              </a:xfrm>
+              <a:prstGeom prst="straightConnector1">
+                <a:avLst/>
+              </a:prstGeom>
+              <a:ln>
+                <a:tailEnd type="triangle"/>
+              </a:ln>
+            </p:spPr>
+            <p:style>
+              <a:lnRef idx="2">
+                <a:schemeClr val="accent1"/>
+              </a:lnRef>
+              <a:fillRef idx="0">
+                <a:schemeClr val="accent1"/>
+              </a:fillRef>
+              <a:effectRef idx="1">
+                <a:schemeClr val="accent1"/>
+              </a:effectRef>
+              <a:fontRef idx="minor">
+                <a:schemeClr val="tx1"/>
+              </a:fontRef>
+            </p:style>
+          </p:cxnSp>
+          <p:cxnSp>
+            <p:nvCxnSpPr>
+              <p:cNvPr id="24" name="Straight Arrow Connector 23">
+                <a:extLst>
+                  <a:ext uri="{FF2B5EF4-FFF2-40B4-BE49-F238E27FC236}">
+                    <a16:creationId xmlns:a16="http://schemas.microsoft.com/office/drawing/2014/main" id="{542FB865-F5C6-BC6F-555E-FC1E78CE2B9C}"/>
+                  </a:ext>
+                </a:extLst>
+              </p:cNvPr>
+              <p:cNvCxnSpPr>
+                <a:cxnSpLocks/>
+                <a:stCxn id="20" idx="0"/>
+                <a:endCxn id="22" idx="2"/>
+              </p:cNvCxnSpPr>
+              <p:nvPr/>
+            </p:nvCxnSpPr>
+            <p:spPr>
+              <a:xfrm flipV="1">
+                <a:off x="8229549" y="3230607"/>
+                <a:ext cx="780662" cy="357182"/>
+              </a:xfrm>
+              <a:prstGeom prst="straightConnector1">
+                <a:avLst/>
+              </a:prstGeom>
+              <a:ln>
+                <a:tailEnd type="triangle"/>
+              </a:ln>
+            </p:spPr>
+            <p:style>
+              <a:lnRef idx="2">
+                <a:schemeClr val="accent1"/>
+              </a:lnRef>
+              <a:fillRef idx="0">
+                <a:schemeClr val="accent1"/>
+              </a:fillRef>
+              <a:effectRef idx="1">
+                <a:schemeClr val="accent1"/>
+              </a:effectRef>
+              <a:fontRef idx="minor">
+                <a:schemeClr val="tx1"/>
+              </a:fontRef>
+            </p:style>
+          </p:cxnSp>
+        </p:grpSp>
+        <p:sp>
+          <p:nvSpPr>
+            <p:cNvPr id="7" name="TextBox 6">
+              <a:extLst>
+                <a:ext uri="{FF2B5EF4-FFF2-40B4-BE49-F238E27FC236}">
+                  <a16:creationId xmlns:a16="http://schemas.microsoft.com/office/drawing/2014/main" id="{D5D8429F-1916-E3EB-9639-C469D19782E1}"/>
+                </a:ext>
+              </a:extLst>
+            </p:cNvPr>
+            <p:cNvSpPr txBox="1"/>
+            <p:nvPr/>
+          </p:nvSpPr>
+          <p:spPr>
+            <a:xfrm>
+              <a:off x="5973620" y="3150562"/>
+              <a:ext cx="500631" cy="400110"/>
+            </a:xfrm>
+            <a:prstGeom prst="rect">
+              <a:avLst/>
+            </a:prstGeom>
+            <a:noFill/>
+          </p:spPr>
+          <p:txBody>
+            <a:bodyPr wrap="square" rtlCol="0">
+              <a:spAutoFit/>
+            </a:bodyPr>
+            <a:lstStyle/>
+            <a:p>
+              <a:r>
+                <a:rPr lang="en-US" sz="2000" b="1" dirty="0">
+                  <a:latin typeface="Arial" panose="020B0604020202020204" pitchFamily="34" charset="0"/>
+                  <a:cs typeface="Arial" panose="020B0604020202020204" pitchFamily="34" charset="0"/>
+                </a:rPr>
+                <a:t>…</a:t>
+              </a:r>
+            </a:p>
+          </p:txBody>
+        </p:sp>
+        <p:cxnSp>
+          <p:nvCxnSpPr>
+            <p:cNvPr id="8" name="Straight Arrow Connector 7">
+              <a:extLst>
+                <a:ext uri="{FF2B5EF4-FFF2-40B4-BE49-F238E27FC236}">
+                  <a16:creationId xmlns:a16="http://schemas.microsoft.com/office/drawing/2014/main" id="{6300756E-267F-32E5-50B1-910DEEF6EFDB}"/>
+                </a:ext>
+              </a:extLst>
+            </p:cNvPr>
+            <p:cNvCxnSpPr>
+              <a:cxnSpLocks/>
+              <a:stCxn id="4" idx="0"/>
+              <a:endCxn id="14" idx="3"/>
+            </p:cNvCxnSpPr>
+            <p:nvPr/>
+          </p:nvCxnSpPr>
+          <p:spPr>
+            <a:xfrm flipH="1" flipV="1">
+              <a:off x="5028236" y="3886410"/>
+              <a:ext cx="1210579" cy="549379"/>
+            </a:xfrm>
+            <a:prstGeom prst="straightConnector1">
+              <a:avLst/>
+            </a:prstGeom>
+            <a:ln>
+              <a:tailEnd type="triangle"/>
+            </a:ln>
+          </p:spPr>
+          <p:style>
+            <a:lnRef idx="2">
+              <a:schemeClr val="accent1"/>
+            </a:lnRef>
+            <a:fillRef idx="0">
+              <a:schemeClr val="accent1"/>
+            </a:fillRef>
+            <a:effectRef idx="1">
+              <a:schemeClr val="accent1"/>
+            </a:effectRef>
+            <a:fontRef idx="minor">
+              <a:schemeClr val="tx1"/>
+            </a:fontRef>
+          </p:style>
+        </p:cxnSp>
+        <p:sp>
+          <p:nvSpPr>
+            <p:cNvPr id="9" name="TextBox 8">
+              <a:extLst>
+                <a:ext uri="{FF2B5EF4-FFF2-40B4-BE49-F238E27FC236}">
+                  <a16:creationId xmlns:a16="http://schemas.microsoft.com/office/drawing/2014/main" id="{C9784A5A-BC47-5991-D2FB-FEB564935F5B}"/>
+                </a:ext>
+              </a:extLst>
+            </p:cNvPr>
+            <p:cNvSpPr txBox="1"/>
+            <p:nvPr/>
+          </p:nvSpPr>
+          <p:spPr>
+            <a:xfrm>
+              <a:off x="7402540" y="4536886"/>
+              <a:ext cx="2396862" cy="338554"/>
+            </a:xfrm>
+            <a:prstGeom prst="rect">
+              <a:avLst/>
+            </a:prstGeom>
+            <a:noFill/>
+          </p:spPr>
+          <p:txBody>
+            <a:bodyPr wrap="square" rtlCol="0">
+              <a:spAutoFit/>
+            </a:bodyPr>
+            <a:lstStyle/>
+            <a:p>
+              <a:r>
+                <a:rPr lang="en-US" sz="1600" b="1" dirty="0">
+                  <a:latin typeface="Arial" panose="020B0604020202020204" pitchFamily="34" charset="0"/>
+                  <a:cs typeface="Arial" panose="020B0604020202020204" pitchFamily="34" charset="0"/>
+                </a:rPr>
+                <a:t>Application Process</a:t>
+              </a:r>
+            </a:p>
+          </p:txBody>
+        </p:sp>
+        <p:grpSp>
+          <p:nvGrpSpPr>
+            <p:cNvPr id="10" name="Group 9">
+              <a:extLst>
+                <a:ext uri="{FF2B5EF4-FFF2-40B4-BE49-F238E27FC236}">
+                  <a16:creationId xmlns:a16="http://schemas.microsoft.com/office/drawing/2014/main" id="{29C85314-76E1-0254-15AE-FD1514DE838E}"/>
+                </a:ext>
+              </a:extLst>
+            </p:cNvPr>
+            <p:cNvGrpSpPr/>
+            <p:nvPr/>
+          </p:nvGrpSpPr>
+          <p:grpSpPr>
+            <a:xfrm>
+              <a:off x="2590116" y="2571250"/>
+              <a:ext cx="3241090" cy="1712804"/>
+              <a:chOff x="6613237" y="2570381"/>
+              <a:chExt cx="3241090" cy="1712804"/>
+            </a:xfrm>
+          </p:grpSpPr>
+          <p:sp>
+            <p:nvSpPr>
+              <p:cNvPr id="13" name="Rectangle 12">
+                <a:extLst>
+                  <a:ext uri="{FF2B5EF4-FFF2-40B4-BE49-F238E27FC236}">
+                    <a16:creationId xmlns:a16="http://schemas.microsoft.com/office/drawing/2014/main" id="{4ABD03C1-B5F1-4DEA-987B-BF6B45B4F2D8}"/>
+                  </a:ext>
+                </a:extLst>
+              </p:cNvPr>
+              <p:cNvSpPr/>
+              <p:nvPr/>
+            </p:nvSpPr>
+            <p:spPr>
+              <a:xfrm>
+                <a:off x="6613237" y="2570381"/>
+                <a:ext cx="3241090" cy="1712804"/>
+              </a:xfrm>
+              <a:prstGeom prst="rect">
+                <a:avLst/>
+              </a:prstGeom>
+              <a:solidFill>
+                <a:schemeClr val="accent1">
+                  <a:alpha val="25046"/>
+                </a:schemeClr>
+              </a:solidFill>
+            </p:spPr>
+            <p:style>
+              <a:lnRef idx="2">
+                <a:schemeClr val="accent1">
+                  <a:shade val="15000"/>
+                </a:schemeClr>
+              </a:lnRef>
+              <a:fillRef idx="1">
+                <a:schemeClr val="accent1"/>
+              </a:fillRef>
+              <a:effectRef idx="0">
+                <a:schemeClr val="accent1"/>
+              </a:effectRef>
+              <a:fontRef idx="minor">
+                <a:schemeClr val="lt1"/>
+              </a:fontRef>
+            </p:style>
+            <p:txBody>
+              <a:bodyPr rtlCol="0" anchor="ctr"/>
+              <a:lstStyle/>
+              <a:p>
+                <a:pPr algn="ctr"/>
+                <a:endParaRPr lang="en-US" sz="1600">
+                  <a:latin typeface="Arial" panose="020B0604020202020204" pitchFamily="34" charset="0"/>
+                  <a:cs typeface="Arial" panose="020B0604020202020204" pitchFamily="34" charset="0"/>
+                </a:endParaRPr>
+              </a:p>
+            </p:txBody>
+          </p:sp>
+          <p:sp>
+            <p:nvSpPr>
+              <p:cNvPr id="14" name="Rectangle 13">
+                <a:extLst>
+                  <a:ext uri="{FF2B5EF4-FFF2-40B4-BE49-F238E27FC236}">
+                    <a16:creationId xmlns:a16="http://schemas.microsoft.com/office/drawing/2014/main" id="{A750AAA0-D195-66EB-4D80-46EC799586D1}"/>
+                  </a:ext>
+                </a:extLst>
+              </p:cNvPr>
+              <p:cNvSpPr/>
+              <p:nvPr/>
+            </p:nvSpPr>
+            <p:spPr>
+              <a:xfrm>
+                <a:off x="7407740" y="3587789"/>
+                <a:ext cx="1643617" cy="595503"/>
+              </a:xfrm>
+              <a:prstGeom prst="rect">
+                <a:avLst/>
+              </a:prstGeom>
+            </p:spPr>
+            <p:style>
+              <a:lnRef idx="2">
+                <a:schemeClr val="accent1">
+                  <a:shade val="15000"/>
+                </a:schemeClr>
+              </a:lnRef>
+              <a:fillRef idx="1">
+                <a:schemeClr val="accent1"/>
+              </a:fillRef>
+              <a:effectRef idx="0">
+                <a:schemeClr val="accent1"/>
+              </a:effectRef>
+              <a:fontRef idx="minor">
+                <a:schemeClr val="lt1"/>
+              </a:fontRef>
+            </p:style>
+            <p:txBody>
+              <a:bodyPr rtlCol="0" anchor="ctr"/>
+              <a:lstStyle/>
+              <a:p>
+                <a:pPr algn="ctr"/>
+                <a:r>
+                  <a:rPr lang="en-US" sz="1600" dirty="0">
+                    <a:latin typeface="Arial" panose="020B0604020202020204" pitchFamily="34" charset="0"/>
+                    <a:cs typeface="Arial" panose="020B0604020202020204" pitchFamily="34" charset="0"/>
+                  </a:rPr>
+                  <a:t>GraphBase*</a:t>
+                </a:r>
+              </a:p>
+            </p:txBody>
+          </p:sp>
+          <p:sp>
+            <p:nvSpPr>
+              <p:cNvPr id="15" name="Rectangle 14">
+                <a:extLst>
+                  <a:ext uri="{FF2B5EF4-FFF2-40B4-BE49-F238E27FC236}">
+                    <a16:creationId xmlns:a16="http://schemas.microsoft.com/office/drawing/2014/main" id="{E16D0CE9-EEB7-248A-BA02-E9AA9CB2DC45}"/>
+                  </a:ext>
+                </a:extLst>
+              </p:cNvPr>
+              <p:cNvSpPr/>
+              <p:nvPr/>
+            </p:nvSpPr>
+            <p:spPr>
+              <a:xfrm>
+                <a:off x="6683801" y="2629453"/>
+                <a:ext cx="1521415" cy="595503"/>
+              </a:xfrm>
+              <a:prstGeom prst="rect">
+                <a:avLst/>
+              </a:prstGeom>
+            </p:spPr>
+            <p:style>
+              <a:lnRef idx="2">
+                <a:schemeClr val="accent1">
+                  <a:shade val="15000"/>
+                </a:schemeClr>
+              </a:lnRef>
+              <a:fillRef idx="1">
+                <a:schemeClr val="accent1"/>
+              </a:fillRef>
+              <a:effectRef idx="0">
+                <a:schemeClr val="accent1"/>
+              </a:effectRef>
+              <a:fontRef idx="minor">
+                <a:schemeClr val="lt1"/>
+              </a:fontRef>
+            </p:style>
+            <p:txBody>
+              <a:bodyPr rtlCol="0" anchor="ctr"/>
+              <a:lstStyle/>
+              <a:p>
+                <a:pPr algn="ctr"/>
+                <a:r>
+                  <a:rPr lang="en-US" sz="1600" dirty="0">
+                    <a:latin typeface="Arial" panose="020B0604020202020204" pitchFamily="34" charset="0"/>
+                    <a:cs typeface="Arial" panose="020B0604020202020204" pitchFamily="34" charset="0"/>
+                  </a:rPr>
+                  <a:t>OutCursor*</a:t>
+                </a:r>
+              </a:p>
+            </p:txBody>
+          </p:sp>
+          <p:sp>
+            <p:nvSpPr>
+              <p:cNvPr id="16" name="Rectangle 15">
+                <a:extLst>
+                  <a:ext uri="{FF2B5EF4-FFF2-40B4-BE49-F238E27FC236}">
+                    <a16:creationId xmlns:a16="http://schemas.microsoft.com/office/drawing/2014/main" id="{7EE0852A-754B-C565-2D96-50F6365AB726}"/>
+                  </a:ext>
+                </a:extLst>
+              </p:cNvPr>
+              <p:cNvSpPr/>
+              <p:nvPr/>
+            </p:nvSpPr>
+            <p:spPr>
+              <a:xfrm>
+                <a:off x="8249503" y="2635104"/>
+                <a:ext cx="1521415" cy="595503"/>
+              </a:xfrm>
+              <a:prstGeom prst="rect">
+                <a:avLst/>
+              </a:prstGeom>
+            </p:spPr>
+            <p:style>
+              <a:lnRef idx="2">
+                <a:schemeClr val="accent1">
+                  <a:shade val="15000"/>
+                </a:schemeClr>
+              </a:lnRef>
+              <a:fillRef idx="1">
+                <a:schemeClr val="accent1"/>
+              </a:fillRef>
+              <a:effectRef idx="0">
+                <a:schemeClr val="accent1"/>
+              </a:effectRef>
+              <a:fontRef idx="minor">
+                <a:schemeClr val="lt1"/>
+              </a:fontRef>
+            </p:style>
+            <p:txBody>
+              <a:bodyPr rtlCol="0" anchor="ctr"/>
+              <a:lstStyle/>
+              <a:p>
+                <a:pPr algn="ctr"/>
+                <a:r>
+                  <a:rPr lang="en-US" sz="1600" dirty="0">
+                    <a:latin typeface="Arial" panose="020B0604020202020204" pitchFamily="34" charset="0"/>
+                    <a:cs typeface="Arial" panose="020B0604020202020204" pitchFamily="34" charset="0"/>
+                  </a:rPr>
+                  <a:t>InCursor*</a:t>
+                </a:r>
+              </a:p>
+            </p:txBody>
+          </p:sp>
+          <p:cxnSp>
+            <p:nvCxnSpPr>
+              <p:cNvPr id="17" name="Straight Arrow Connector 16">
+                <a:extLst>
+                  <a:ext uri="{FF2B5EF4-FFF2-40B4-BE49-F238E27FC236}">
+                    <a16:creationId xmlns:a16="http://schemas.microsoft.com/office/drawing/2014/main" id="{FB61D645-A9DE-4819-149A-BBC4A4F7F50B}"/>
+                  </a:ext>
+                </a:extLst>
+              </p:cNvPr>
+              <p:cNvCxnSpPr>
+                <a:cxnSpLocks/>
+                <a:stCxn id="14" idx="0"/>
+                <a:endCxn id="15" idx="2"/>
+              </p:cNvCxnSpPr>
+              <p:nvPr/>
+            </p:nvCxnSpPr>
+            <p:spPr>
+              <a:xfrm flipH="1" flipV="1">
+                <a:off x="7444509" y="3224956"/>
+                <a:ext cx="785040" cy="362833"/>
+              </a:xfrm>
+              <a:prstGeom prst="straightConnector1">
+                <a:avLst/>
+              </a:prstGeom>
+              <a:ln>
+                <a:tailEnd type="triangle"/>
+              </a:ln>
+            </p:spPr>
+            <p:style>
+              <a:lnRef idx="2">
+                <a:schemeClr val="accent1"/>
+              </a:lnRef>
+              <a:fillRef idx="0">
+                <a:schemeClr val="accent1"/>
+              </a:fillRef>
+              <a:effectRef idx="1">
+                <a:schemeClr val="accent1"/>
+              </a:effectRef>
+              <a:fontRef idx="minor">
+                <a:schemeClr val="tx1"/>
+              </a:fontRef>
+            </p:style>
+          </p:cxnSp>
+          <p:cxnSp>
+            <p:nvCxnSpPr>
+              <p:cNvPr id="18" name="Straight Arrow Connector 17">
+                <a:extLst>
+                  <a:ext uri="{FF2B5EF4-FFF2-40B4-BE49-F238E27FC236}">
+                    <a16:creationId xmlns:a16="http://schemas.microsoft.com/office/drawing/2014/main" id="{97DFB34C-C990-CAE1-C2CD-1084952AC18D}"/>
+                  </a:ext>
+                </a:extLst>
+              </p:cNvPr>
+              <p:cNvCxnSpPr>
+                <a:cxnSpLocks/>
+                <a:stCxn id="14" idx="0"/>
+                <a:endCxn id="16" idx="2"/>
+              </p:cNvCxnSpPr>
+              <p:nvPr/>
+            </p:nvCxnSpPr>
+            <p:spPr>
+              <a:xfrm flipV="1">
+                <a:off x="8229549" y="3230607"/>
+                <a:ext cx="780662" cy="357182"/>
+              </a:xfrm>
+              <a:prstGeom prst="straightConnector1">
+                <a:avLst/>
+              </a:prstGeom>
+              <a:ln>
+                <a:tailEnd type="triangle"/>
+              </a:ln>
+            </p:spPr>
+            <p:style>
+              <a:lnRef idx="2">
+                <a:schemeClr val="accent1"/>
+              </a:lnRef>
+              <a:fillRef idx="0">
+                <a:schemeClr val="accent1"/>
+              </a:fillRef>
+              <a:effectRef idx="1">
+                <a:schemeClr val="accent1"/>
+              </a:effectRef>
+              <a:fontRef idx="minor">
+                <a:schemeClr val="tx1"/>
+              </a:fontRef>
+            </p:style>
+          </p:cxnSp>
+        </p:grpSp>
+        <p:sp>
+          <p:nvSpPr>
+            <p:cNvPr id="11" name="TextBox 10">
+              <a:extLst>
+                <a:ext uri="{FF2B5EF4-FFF2-40B4-BE49-F238E27FC236}">
+                  <a16:creationId xmlns:a16="http://schemas.microsoft.com/office/drawing/2014/main" id="{BB8F0CE2-63F9-EA2E-1F3B-D11164A7E0C5}"/>
+                </a:ext>
+              </a:extLst>
+            </p:cNvPr>
+            <p:cNvSpPr txBox="1"/>
+            <p:nvPr/>
+          </p:nvSpPr>
+          <p:spPr>
+            <a:xfrm>
+              <a:off x="2532756" y="3921475"/>
+              <a:ext cx="817853" cy="307777"/>
+            </a:xfrm>
+            <a:prstGeom prst="rect">
+              <a:avLst/>
+            </a:prstGeom>
+            <a:noFill/>
+          </p:spPr>
+          <p:txBody>
+            <a:bodyPr wrap="none" rtlCol="0">
+              <a:spAutoFit/>
+            </a:bodyPr>
+            <a:lstStyle/>
+            <a:p>
+              <a:r>
+                <a:rPr lang="en-US" sz="1400" dirty="0">
+                  <a:latin typeface="Arial" panose="020B0604020202020204" pitchFamily="34" charset="0"/>
+                  <a:cs typeface="Arial" panose="020B0604020202020204" pitchFamily="34" charset="0"/>
+                </a:rPr>
+                <a:t>Thread</a:t>
+              </a:r>
+              <a:r>
+                <a:rPr lang="en-US" sz="1400" baseline="-25000" dirty="0">
+                  <a:latin typeface="Arial" panose="020B0604020202020204" pitchFamily="34" charset="0"/>
+                  <a:cs typeface="Arial" panose="020B0604020202020204" pitchFamily="34" charset="0"/>
+                </a:rPr>
+                <a:t>0</a:t>
+              </a:r>
+              <a:endParaRPr lang="en-US" sz="1600" baseline="-25000" dirty="0">
+                <a:latin typeface="Arial" panose="020B0604020202020204" pitchFamily="34" charset="0"/>
+                <a:cs typeface="Arial" panose="020B0604020202020204" pitchFamily="34" charset="0"/>
+              </a:endParaRPr>
+            </a:p>
+          </p:txBody>
+        </p:sp>
+        <p:sp>
+          <p:nvSpPr>
+            <p:cNvPr id="12" name="TextBox 11">
+              <a:extLst>
+                <a:ext uri="{FF2B5EF4-FFF2-40B4-BE49-F238E27FC236}">
+                  <a16:creationId xmlns:a16="http://schemas.microsoft.com/office/drawing/2014/main" id="{A8CEA9AD-A9E0-4D45-1BB9-0A8A92F82BCF}"/>
+                </a:ext>
+              </a:extLst>
+            </p:cNvPr>
+            <p:cNvSpPr txBox="1"/>
+            <p:nvPr/>
+          </p:nvSpPr>
+          <p:spPr>
+            <a:xfrm>
+              <a:off x="9063944" y="3965665"/>
+              <a:ext cx="817853" cy="307777"/>
+            </a:xfrm>
+            <a:prstGeom prst="rect">
+              <a:avLst/>
+            </a:prstGeom>
+            <a:noFill/>
+          </p:spPr>
+          <p:txBody>
+            <a:bodyPr wrap="none" rtlCol="0">
+              <a:spAutoFit/>
+            </a:bodyPr>
+            <a:lstStyle/>
+            <a:p>
+              <a:r>
+                <a:rPr lang="en-US" sz="1400" dirty="0">
+                  <a:latin typeface="Arial" panose="020B0604020202020204" pitchFamily="34" charset="0"/>
+                  <a:cs typeface="Arial" panose="020B0604020202020204" pitchFamily="34" charset="0"/>
+                </a:rPr>
+                <a:t>Thread</a:t>
+              </a:r>
+              <a:r>
+                <a:rPr lang="en-US" sz="1400" baseline="-25000" dirty="0">
+                  <a:latin typeface="Arial" panose="020B0604020202020204" pitchFamily="34" charset="0"/>
+                  <a:cs typeface="Arial" panose="020B0604020202020204" pitchFamily="34" charset="0"/>
+                </a:rPr>
+                <a:t>n</a:t>
+              </a:r>
+              <a:endParaRPr lang="en-US" sz="1600" baseline="-25000" dirty="0">
+                <a:latin typeface="Arial" panose="020B0604020202020204" pitchFamily="34" charset="0"/>
+                <a:cs typeface="Arial" panose="020B0604020202020204" pitchFamily="34" charset="0"/>
+              </a:endParaRPr>
+            </a:p>
+          </p:txBody>
+        </p:sp>
+      </p:grpSp>
+    </p:spTree>
+    <p:extLst>
+      <p:ext uri="{BB962C8B-B14F-4D97-AF65-F5344CB8AC3E}">
+        <p14:creationId xmlns:p14="http://schemas.microsoft.com/office/powerpoint/2010/main" val="4154462903"/>
+      </p:ext>
+    </p:extLst>
+  </p:cSld>
+  <p:clrMapOvr>
+    <a:masterClrMapping/>
+  </p:clrMapOvr>
+</p:sld>
+</file>
+
+<file path=ppt/slides/slide3.xml><?xml version="1.0" encoding="utf-8"?>
 <p:sld xmlns:a="http://schemas.openxmlformats.org/drawingml/2006/main" xmlns:r="http://schemas.openxmlformats.org/officeDocument/2006/relationships" xmlns:p="http://schemas.openxmlformats.org/presentationml/2006/main">
   <p:cSld>
     <p:spTree>
@@ -5553,6 +6668,887 @@
 </p:sld>
 </file>
 
+<file path=ppt/slides/slide4.xml><?xml version="1.0" encoding="utf-8"?>
+<p:sld xmlns:a="http://schemas.openxmlformats.org/drawingml/2006/main" xmlns:r="http://schemas.openxmlformats.org/officeDocument/2006/relationships" xmlns:p="http://schemas.openxmlformats.org/presentationml/2006/main">
+  <p:cSld>
+    <p:spTree>
+      <p:nvGrpSpPr>
+        <p:cNvPr id="1" name=""/>
+        <p:cNvGrpSpPr/>
+        <p:nvPr/>
+      </p:nvGrpSpPr>
+      <p:grpSpPr>
+        <a:xfrm>
+          <a:off x="0" y="0"/>
+          <a:ext cx="0" cy="0"/>
+          <a:chOff x="0" y="0"/>
+          <a:chExt cx="0" cy="0"/>
+        </a:xfrm>
+      </p:grpSpPr>
+      <p:sp>
+        <p:nvSpPr>
+          <p:cNvPr id="2" name="Freeform 1">
+            <a:extLst>
+              <a:ext uri="{FF2B5EF4-FFF2-40B4-BE49-F238E27FC236}">
+                <a16:creationId xmlns:a16="http://schemas.microsoft.com/office/drawing/2014/main" id="{48E62A24-1A10-1BA0-A4E0-52B50F56700B}"/>
+              </a:ext>
+            </a:extLst>
+          </p:cNvPr>
+          <p:cNvSpPr/>
+          <p:nvPr/>
+        </p:nvSpPr>
+        <p:spPr>
+          <a:xfrm>
+            <a:off x="4010464" y="2105845"/>
+            <a:ext cx="4171071" cy="566627"/>
+          </a:xfrm>
+          <a:custGeom>
+            <a:avLst/>
+            <a:gdLst>
+              <a:gd name="connsiteX0" fmla="*/ 164145 w 3004458"/>
+              <a:gd name="connsiteY0" fmla="*/ 0 h 433140"/>
+              <a:gd name="connsiteX1" fmla="*/ 2822261 w 3004458"/>
+              <a:gd name="connsiteY1" fmla="*/ 2 h 433140"/>
+              <a:gd name="connsiteX2" fmla="*/ 2822265 w 3004458"/>
+              <a:gd name="connsiteY2" fmla="*/ 1 h 433140"/>
+              <a:gd name="connsiteX3" fmla="*/ 2822269 w 3004458"/>
+              <a:gd name="connsiteY3" fmla="*/ 2 h 433140"/>
+              <a:gd name="connsiteX4" fmla="*/ 2867810 w 3004458"/>
+              <a:gd name="connsiteY4" fmla="*/ 2 h 433140"/>
+              <a:gd name="connsiteX5" fmla="*/ 2867813 w 3004458"/>
+              <a:gd name="connsiteY5" fmla="*/ 0 h 433140"/>
+              <a:gd name="connsiteX6" fmla="*/ 2878724 w 3004458"/>
+              <a:gd name="connsiteY6" fmla="*/ 4401 h 433140"/>
+              <a:gd name="connsiteX7" fmla="*/ 2887072 w 3004458"/>
+              <a:gd name="connsiteY7" fmla="*/ 14765 h 433140"/>
+              <a:gd name="connsiteX8" fmla="*/ 2893183 w 3004458"/>
+              <a:gd name="connsiteY8" fmla="*/ 17020 h 433140"/>
+              <a:gd name="connsiteX9" fmla="*/ 3004458 w 3004458"/>
+              <a:gd name="connsiteY9" fmla="*/ 216570 h 433140"/>
+              <a:gd name="connsiteX10" fmla="*/ 2893183 w 3004458"/>
+              <a:gd name="connsiteY10" fmla="*/ 416120 h 433140"/>
+              <a:gd name="connsiteX11" fmla="*/ 2887072 w 3004458"/>
+              <a:gd name="connsiteY11" fmla="*/ 418375 h 433140"/>
+              <a:gd name="connsiteX12" fmla="*/ 2878724 w 3004458"/>
+              <a:gd name="connsiteY12" fmla="*/ 428740 h 433140"/>
+              <a:gd name="connsiteX13" fmla="*/ 2867813 w 3004458"/>
+              <a:gd name="connsiteY13" fmla="*/ 433140 h 433140"/>
+              <a:gd name="connsiteX14" fmla="*/ 182197 w 3004458"/>
+              <a:gd name="connsiteY14" fmla="*/ 433139 h 433140"/>
+              <a:gd name="connsiteX15" fmla="*/ 182193 w 3004458"/>
+              <a:gd name="connsiteY15" fmla="*/ 433139 h 433140"/>
+              <a:gd name="connsiteX16" fmla="*/ 182189 w 3004458"/>
+              <a:gd name="connsiteY16" fmla="*/ 433139 h 433140"/>
+              <a:gd name="connsiteX17" fmla="*/ 164145 w 3004458"/>
+              <a:gd name="connsiteY17" fmla="*/ 433139 h 433140"/>
+              <a:gd name="connsiteX18" fmla="*/ 156515 w 3004458"/>
+              <a:gd name="connsiteY18" fmla="*/ 430062 h 433140"/>
+              <a:gd name="connsiteX19" fmla="*/ 145475 w 3004458"/>
+              <a:gd name="connsiteY19" fmla="*/ 428739 h 433140"/>
+              <a:gd name="connsiteX20" fmla="*/ 0 w 3004458"/>
+              <a:gd name="connsiteY20" fmla="*/ 216570 h 433140"/>
+              <a:gd name="connsiteX21" fmla="*/ 145475 w 3004458"/>
+              <a:gd name="connsiteY21" fmla="*/ 4401 h 433140"/>
+              <a:gd name="connsiteX22" fmla="*/ 156512 w 3004458"/>
+              <a:gd name="connsiteY22" fmla="*/ 3079 h 433140"/>
+            </a:gdLst>
+            <a:ahLst/>
+            <a:cxnLst>
+              <a:cxn ang="0">
+                <a:pos x="connsiteX0" y="connsiteY0"/>
+              </a:cxn>
+              <a:cxn ang="0">
+                <a:pos x="connsiteX1" y="connsiteY1"/>
+              </a:cxn>
+              <a:cxn ang="0">
+                <a:pos x="connsiteX2" y="connsiteY2"/>
+              </a:cxn>
+              <a:cxn ang="0">
+                <a:pos x="connsiteX3" y="connsiteY3"/>
+              </a:cxn>
+              <a:cxn ang="0">
+                <a:pos x="connsiteX4" y="connsiteY4"/>
+              </a:cxn>
+              <a:cxn ang="0">
+                <a:pos x="connsiteX5" y="connsiteY5"/>
+              </a:cxn>
+              <a:cxn ang="0">
+                <a:pos x="connsiteX6" y="connsiteY6"/>
+              </a:cxn>
+              <a:cxn ang="0">
+                <a:pos x="connsiteX7" y="connsiteY7"/>
+              </a:cxn>
+              <a:cxn ang="0">
+                <a:pos x="connsiteX8" y="connsiteY8"/>
+              </a:cxn>
+              <a:cxn ang="0">
+                <a:pos x="connsiteX9" y="connsiteY9"/>
+              </a:cxn>
+              <a:cxn ang="0">
+                <a:pos x="connsiteX10" y="connsiteY10"/>
+              </a:cxn>
+              <a:cxn ang="0">
+                <a:pos x="connsiteX11" y="connsiteY11"/>
+              </a:cxn>
+              <a:cxn ang="0">
+                <a:pos x="connsiteX12" y="connsiteY12"/>
+              </a:cxn>
+              <a:cxn ang="0">
+                <a:pos x="connsiteX13" y="connsiteY13"/>
+              </a:cxn>
+              <a:cxn ang="0">
+                <a:pos x="connsiteX14" y="connsiteY14"/>
+              </a:cxn>
+              <a:cxn ang="0">
+                <a:pos x="connsiteX15" y="connsiteY15"/>
+              </a:cxn>
+              <a:cxn ang="0">
+                <a:pos x="connsiteX16" y="connsiteY16"/>
+              </a:cxn>
+              <a:cxn ang="0">
+                <a:pos x="connsiteX17" y="connsiteY17"/>
+              </a:cxn>
+              <a:cxn ang="0">
+                <a:pos x="connsiteX18" y="connsiteY18"/>
+              </a:cxn>
+              <a:cxn ang="0">
+                <a:pos x="connsiteX19" y="connsiteY19"/>
+              </a:cxn>
+              <a:cxn ang="0">
+                <a:pos x="connsiteX20" y="connsiteY20"/>
+              </a:cxn>
+              <a:cxn ang="0">
+                <a:pos x="connsiteX21" y="connsiteY21"/>
+              </a:cxn>
+              <a:cxn ang="0">
+                <a:pos x="connsiteX22" y="connsiteY22"/>
+              </a:cxn>
+            </a:cxnLst>
+            <a:rect l="l" t="t" r="r" b="b"/>
+            <a:pathLst>
+              <a:path w="3004458" h="433140">
+                <a:moveTo>
+                  <a:pt x="164145" y="0"/>
+                </a:moveTo>
+                <a:lnTo>
+                  <a:pt x="2822261" y="2"/>
+                </a:lnTo>
+                <a:lnTo>
+                  <a:pt x="2822265" y="1"/>
+                </a:lnTo>
+                <a:lnTo>
+                  <a:pt x="2822269" y="2"/>
+                </a:lnTo>
+                <a:lnTo>
+                  <a:pt x="2867810" y="2"/>
+                </a:lnTo>
+                <a:lnTo>
+                  <a:pt x="2867813" y="0"/>
+                </a:lnTo>
+                <a:cubicBezTo>
+                  <a:pt x="2871551" y="0"/>
+                  <a:pt x="2875200" y="1516"/>
+                  <a:pt x="2878724" y="4401"/>
+                </a:cubicBezTo>
+                <a:lnTo>
+                  <a:pt x="2887072" y="14765"/>
+                </a:lnTo>
+                <a:lnTo>
+                  <a:pt x="2893183" y="17020"/>
+                </a:lnTo>
+                <a:cubicBezTo>
+                  <a:pt x="2958575" y="49897"/>
+                  <a:pt x="3004458" y="126864"/>
+                  <a:pt x="3004458" y="216570"/>
+                </a:cubicBezTo>
+                <a:cubicBezTo>
+                  <a:pt x="3004458" y="306276"/>
+                  <a:pt x="2958575" y="383243"/>
+                  <a:pt x="2893183" y="416120"/>
+                </a:cubicBezTo>
+                <a:lnTo>
+                  <a:pt x="2887072" y="418375"/>
+                </a:lnTo>
+                <a:lnTo>
+                  <a:pt x="2878724" y="428740"/>
+                </a:lnTo>
+                <a:cubicBezTo>
+                  <a:pt x="2875200" y="431625"/>
+                  <a:pt x="2871551" y="433140"/>
+                  <a:pt x="2867813" y="433140"/>
+                </a:cubicBezTo>
+                <a:lnTo>
+                  <a:pt x="182197" y="433139"/>
+                </a:lnTo>
+                <a:lnTo>
+                  <a:pt x="182193" y="433139"/>
+                </a:lnTo>
+                <a:lnTo>
+                  <a:pt x="182189" y="433139"/>
+                </a:lnTo>
+                <a:lnTo>
+                  <a:pt x="164145" y="433139"/>
+                </a:lnTo>
+                <a:lnTo>
+                  <a:pt x="156515" y="430062"/>
+                </a:lnTo>
+                <a:lnTo>
+                  <a:pt x="145475" y="428739"/>
+                </a:lnTo>
+                <a:cubicBezTo>
+                  <a:pt x="62453" y="408545"/>
+                  <a:pt x="0" y="321227"/>
+                  <a:pt x="0" y="216570"/>
+                </a:cubicBezTo>
+                <a:cubicBezTo>
+                  <a:pt x="0" y="111913"/>
+                  <a:pt x="62453" y="24595"/>
+                  <a:pt x="145475" y="4401"/>
+                </a:cubicBezTo>
+                <a:lnTo>
+                  <a:pt x="156512" y="3079"/>
+                </a:lnTo>
+                <a:close/>
+              </a:path>
+            </a:pathLst>
+          </a:custGeom>
+          <a:gradFill flip="none" rotWithShape="1">
+            <a:gsLst>
+              <a:gs pos="0">
+                <a:srgbClr val="FFF33B"/>
+              </a:gs>
+              <a:gs pos="23000">
+                <a:srgbClr val="FDC70C"/>
+              </a:gs>
+              <a:gs pos="69000">
+                <a:srgbClr val="ED683C"/>
+              </a:gs>
+              <a:gs pos="44022">
+                <a:srgbClr val="F3903F"/>
+              </a:gs>
+              <a:gs pos="97000">
+                <a:srgbClr val="E93E3A"/>
+              </a:gs>
+            </a:gsLst>
+            <a:lin ang="0" scaled="0"/>
+            <a:tileRect/>
+          </a:gradFill>
+        </p:spPr>
+        <p:style>
+          <a:lnRef idx="2">
+            <a:schemeClr val="accent1">
+              <a:shade val="15000"/>
+            </a:schemeClr>
+          </a:lnRef>
+          <a:fillRef idx="1">
+            <a:schemeClr val="accent1"/>
+          </a:fillRef>
+          <a:effectRef idx="0">
+            <a:schemeClr val="accent1"/>
+          </a:effectRef>
+          <a:fontRef idx="minor">
+            <a:schemeClr val="lt1"/>
+          </a:fontRef>
+        </p:style>
+        <p:txBody>
+          <a:bodyPr wrap="square" rtlCol="0" anchor="ctr">
+            <a:noAutofit/>
+          </a:bodyPr>
+          <a:lstStyle/>
+          <a:p>
+            <a:pPr algn="ctr"/>
+            <a:endParaRPr lang="en-US" dirty="0"/>
+          </a:p>
+        </p:txBody>
+      </p:sp>
+      <p:cxnSp>
+        <p:nvCxnSpPr>
+          <p:cNvPr id="3" name="Straight Arrow Connector 2">
+            <a:extLst>
+              <a:ext uri="{FF2B5EF4-FFF2-40B4-BE49-F238E27FC236}">
+                <a16:creationId xmlns:a16="http://schemas.microsoft.com/office/drawing/2014/main" id="{CAF63B08-3CFC-F5E4-8D4B-AFEFFBEEB69A}"/>
+              </a:ext>
+            </a:extLst>
+          </p:cNvPr>
+          <p:cNvCxnSpPr/>
+          <p:nvPr/>
+        </p:nvCxnSpPr>
+        <p:spPr>
+          <a:xfrm>
+            <a:off x="4355123" y="2824611"/>
+            <a:ext cx="3334043" cy="0"/>
+          </a:xfrm>
+          <a:prstGeom prst="straightConnector1">
+            <a:avLst/>
+          </a:prstGeom>
+          <a:ln w="19050">
+            <a:tailEnd type="triangle"/>
+          </a:ln>
+        </p:spPr>
+        <p:style>
+          <a:lnRef idx="1">
+            <a:schemeClr val="accent1"/>
+          </a:lnRef>
+          <a:fillRef idx="0">
+            <a:schemeClr val="accent1"/>
+          </a:fillRef>
+          <a:effectRef idx="0">
+            <a:schemeClr val="accent1"/>
+          </a:effectRef>
+          <a:fontRef idx="minor">
+            <a:schemeClr val="tx1"/>
+          </a:fontRef>
+        </p:style>
+      </p:cxnSp>
+      <p:sp>
+        <p:nvSpPr>
+          <p:cNvPr id="4" name="TextBox 3">
+            <a:extLst>
+              <a:ext uri="{FF2B5EF4-FFF2-40B4-BE49-F238E27FC236}">
+                <a16:creationId xmlns:a16="http://schemas.microsoft.com/office/drawing/2014/main" id="{3863E097-2297-4C01-AF36-571EF498197E}"/>
+              </a:ext>
+            </a:extLst>
+          </p:cNvPr>
+          <p:cNvSpPr txBox="1"/>
+          <p:nvPr/>
+        </p:nvSpPr>
+        <p:spPr>
+          <a:xfrm>
+            <a:off x="3313997" y="2149252"/>
+            <a:ext cx="631904" cy="523220"/>
+          </a:xfrm>
+          <a:prstGeom prst="rect">
+            <a:avLst/>
+          </a:prstGeom>
+          <a:noFill/>
+        </p:spPr>
+        <p:txBody>
+          <a:bodyPr wrap="none" rtlCol="0">
+            <a:spAutoFit/>
+          </a:bodyPr>
+          <a:lstStyle/>
+          <a:p>
+            <a:r>
+              <a:rPr lang="en-US" dirty="0"/>
+              <a:t>Point</a:t>
+            </a:r>
+            <a:br>
+              <a:rPr lang="en-US" dirty="0"/>
+            </a:br>
+            <a:r>
+              <a:rPr lang="en-US" dirty="0"/>
+              <a:t>query</a:t>
+            </a:r>
+          </a:p>
+        </p:txBody>
+      </p:sp>
+      <p:sp>
+        <p:nvSpPr>
+          <p:cNvPr id="5" name="TextBox 4">
+            <a:extLst>
+              <a:ext uri="{FF2B5EF4-FFF2-40B4-BE49-F238E27FC236}">
+                <a16:creationId xmlns:a16="http://schemas.microsoft.com/office/drawing/2014/main" id="{7F1250BF-5C44-D4DB-2D05-461F5705AF86}"/>
+              </a:ext>
+            </a:extLst>
+          </p:cNvPr>
+          <p:cNvSpPr txBox="1"/>
+          <p:nvPr/>
+        </p:nvSpPr>
+        <p:spPr>
+          <a:xfrm>
+            <a:off x="8217166" y="2064846"/>
+            <a:ext cx="1584756" cy="646331"/>
+          </a:xfrm>
+          <a:prstGeom prst="rect">
+            <a:avLst/>
+          </a:prstGeom>
+          <a:noFill/>
+        </p:spPr>
+        <p:txBody>
+          <a:bodyPr wrap="square" rtlCol="0">
+            <a:spAutoFit/>
+          </a:bodyPr>
+          <a:lstStyle/>
+          <a:p>
+            <a:r>
+              <a:rPr lang="en-US" dirty="0"/>
+              <a:t>Whole graph</a:t>
+            </a:r>
+            <a:br>
+              <a:rPr lang="en-US" dirty="0"/>
+            </a:br>
+            <a:r>
+              <a:rPr lang="en-US" dirty="0"/>
+              <a:t>Analytics</a:t>
+            </a:r>
+          </a:p>
+        </p:txBody>
+      </p:sp>
+      <p:sp>
+        <p:nvSpPr>
+          <p:cNvPr id="6" name="TextBox 5">
+            <a:extLst>
+              <a:ext uri="{FF2B5EF4-FFF2-40B4-BE49-F238E27FC236}">
+                <a16:creationId xmlns:a16="http://schemas.microsoft.com/office/drawing/2014/main" id="{C7361052-A6F4-08FB-F88F-A70C7CA33D3A}"/>
+              </a:ext>
+            </a:extLst>
+          </p:cNvPr>
+          <p:cNvSpPr txBox="1"/>
+          <p:nvPr/>
+        </p:nvSpPr>
+        <p:spPr>
+          <a:xfrm>
+            <a:off x="4593947" y="2746219"/>
+            <a:ext cx="3095219" cy="369332"/>
+          </a:xfrm>
+          <a:prstGeom prst="rect">
+            <a:avLst/>
+          </a:prstGeom>
+          <a:noFill/>
+        </p:spPr>
+        <p:txBody>
+          <a:bodyPr wrap="square" rtlCol="0">
+            <a:spAutoFit/>
+          </a:bodyPr>
+          <a:lstStyle/>
+          <a:p>
+            <a:r>
+              <a:rPr lang="en-US" dirty="0"/>
+              <a:t>Increasing query complexity</a:t>
+            </a:r>
+          </a:p>
+        </p:txBody>
+      </p:sp>
+      <p:sp>
+        <p:nvSpPr>
+          <p:cNvPr id="11" name="TextBox 10">
+            <a:extLst>
+              <a:ext uri="{FF2B5EF4-FFF2-40B4-BE49-F238E27FC236}">
+                <a16:creationId xmlns:a16="http://schemas.microsoft.com/office/drawing/2014/main" id="{B03BAB5E-F553-FB97-A96E-F459C495EA7F}"/>
+              </a:ext>
+            </a:extLst>
+          </p:cNvPr>
+          <p:cNvSpPr txBox="1"/>
+          <p:nvPr/>
+        </p:nvSpPr>
+        <p:spPr>
+          <a:xfrm>
+            <a:off x="4101676" y="2236299"/>
+            <a:ext cx="652743" cy="307777"/>
+          </a:xfrm>
+          <a:prstGeom prst="rect">
+            <a:avLst/>
+          </a:prstGeom>
+          <a:noFill/>
+        </p:spPr>
+        <p:txBody>
+          <a:bodyPr wrap="none" rtlCol="0">
+            <a:spAutoFit/>
+          </a:bodyPr>
+          <a:lstStyle/>
+          <a:p>
+            <a:r>
+              <a:rPr lang="en-US" dirty="0"/>
+              <a:t>OLTP</a:t>
+            </a:r>
+          </a:p>
+        </p:txBody>
+      </p:sp>
+      <p:sp>
+        <p:nvSpPr>
+          <p:cNvPr id="12" name="TextBox 11">
+            <a:extLst>
+              <a:ext uri="{FF2B5EF4-FFF2-40B4-BE49-F238E27FC236}">
+                <a16:creationId xmlns:a16="http://schemas.microsoft.com/office/drawing/2014/main" id="{5AB9E7F7-605B-C25E-70B9-7BE8157F4C12}"/>
+              </a:ext>
+            </a:extLst>
+          </p:cNvPr>
+          <p:cNvSpPr txBox="1"/>
+          <p:nvPr/>
+        </p:nvSpPr>
+        <p:spPr>
+          <a:xfrm>
+            <a:off x="7517343" y="2236299"/>
+            <a:ext cx="663964" cy="307777"/>
+          </a:xfrm>
+          <a:prstGeom prst="rect">
+            <a:avLst/>
+          </a:prstGeom>
+          <a:noFill/>
+        </p:spPr>
+        <p:txBody>
+          <a:bodyPr wrap="none" rtlCol="0">
+            <a:spAutoFit/>
+          </a:bodyPr>
+          <a:lstStyle/>
+          <a:p>
+            <a:r>
+              <a:rPr lang="en-US" dirty="0"/>
+              <a:t>OLAP</a:t>
+            </a:r>
+          </a:p>
+        </p:txBody>
+      </p:sp>
+      <p:grpSp>
+        <p:nvGrpSpPr>
+          <p:cNvPr id="22" name="Group 21">
+            <a:extLst>
+              <a:ext uri="{FF2B5EF4-FFF2-40B4-BE49-F238E27FC236}">
+                <a16:creationId xmlns:a16="http://schemas.microsoft.com/office/drawing/2014/main" id="{4A7A155B-1A5B-3774-6851-F670F2F08D3F}"/>
+              </a:ext>
+            </a:extLst>
+          </p:cNvPr>
+          <p:cNvGrpSpPr/>
+          <p:nvPr/>
+        </p:nvGrpSpPr>
+        <p:grpSpPr>
+          <a:xfrm>
+            <a:off x="2554934" y="2921891"/>
+            <a:ext cx="7173244" cy="443079"/>
+            <a:chOff x="2572799" y="3105834"/>
+            <a:chExt cx="7173244" cy="443079"/>
+          </a:xfrm>
+        </p:grpSpPr>
+        <p:cxnSp>
+          <p:nvCxnSpPr>
+            <p:cNvPr id="7" name="Straight Arrow Connector 6">
+              <a:extLst>
+                <a:ext uri="{FF2B5EF4-FFF2-40B4-BE49-F238E27FC236}">
+                  <a16:creationId xmlns:a16="http://schemas.microsoft.com/office/drawing/2014/main" id="{6253028C-3DB0-88E1-D6E3-0E473B6E5E1D}"/>
+                </a:ext>
+              </a:extLst>
+            </p:cNvPr>
+            <p:cNvCxnSpPr>
+              <a:cxnSpLocks/>
+            </p:cNvCxnSpPr>
+            <p:nvPr/>
+          </p:nvCxnSpPr>
+          <p:spPr>
+            <a:xfrm>
+              <a:off x="4101676" y="3364247"/>
+              <a:ext cx="4282738" cy="0"/>
+            </a:xfrm>
+            <a:prstGeom prst="straightConnector1">
+              <a:avLst/>
+            </a:prstGeom>
+            <a:ln w="19050">
+              <a:tailEnd type="triangle"/>
+            </a:ln>
+          </p:spPr>
+          <p:style>
+            <a:lnRef idx="1">
+              <a:schemeClr val="accent1"/>
+            </a:lnRef>
+            <a:fillRef idx="0">
+              <a:schemeClr val="accent1"/>
+            </a:fillRef>
+            <a:effectRef idx="0">
+              <a:schemeClr val="accent1"/>
+            </a:effectRef>
+            <a:fontRef idx="minor">
+              <a:schemeClr val="tx1"/>
+            </a:fontRef>
+          </p:style>
+        </p:cxnSp>
+        <p:sp>
+          <p:nvSpPr>
+            <p:cNvPr id="13" name="TextBox 12">
+              <a:extLst>
+                <a:ext uri="{FF2B5EF4-FFF2-40B4-BE49-F238E27FC236}">
+                  <a16:creationId xmlns:a16="http://schemas.microsoft.com/office/drawing/2014/main" id="{15563DA9-C6B0-0818-D281-47FDCFE7CD3D}"/>
+                </a:ext>
+              </a:extLst>
+            </p:cNvPr>
+            <p:cNvSpPr txBox="1"/>
+            <p:nvPr/>
+          </p:nvSpPr>
+          <p:spPr>
+            <a:xfrm>
+              <a:off x="2572799" y="3105834"/>
+              <a:ext cx="1528877" cy="369332"/>
+            </a:xfrm>
+            <a:prstGeom prst="rect">
+              <a:avLst/>
+            </a:prstGeom>
+            <a:noFill/>
+          </p:spPr>
+          <p:txBody>
+            <a:bodyPr wrap="square" rtlCol="0">
+              <a:spAutoFit/>
+            </a:bodyPr>
+            <a:lstStyle/>
+            <a:p>
+              <a:pPr algn="ctr"/>
+              <a:r>
+                <a:rPr lang="en-US" dirty="0"/>
+                <a:t>Write-heavy</a:t>
+              </a:r>
+            </a:p>
+          </p:txBody>
+        </p:sp>
+        <p:sp>
+          <p:nvSpPr>
+            <p:cNvPr id="14" name="TextBox 13">
+              <a:extLst>
+                <a:ext uri="{FF2B5EF4-FFF2-40B4-BE49-F238E27FC236}">
+                  <a16:creationId xmlns:a16="http://schemas.microsoft.com/office/drawing/2014/main" id="{D96D33A7-345F-D658-1A5F-C14A17749A85}"/>
+                </a:ext>
+              </a:extLst>
+            </p:cNvPr>
+            <p:cNvSpPr txBox="1"/>
+            <p:nvPr/>
+          </p:nvSpPr>
+          <p:spPr>
+            <a:xfrm>
+              <a:off x="8217166" y="3179581"/>
+              <a:ext cx="1528877" cy="369332"/>
+            </a:xfrm>
+            <a:prstGeom prst="rect">
+              <a:avLst/>
+            </a:prstGeom>
+            <a:noFill/>
+          </p:spPr>
+          <p:txBody>
+            <a:bodyPr wrap="square" rtlCol="0">
+              <a:spAutoFit/>
+            </a:bodyPr>
+            <a:lstStyle/>
+            <a:p>
+              <a:pPr algn="ctr"/>
+              <a:r>
+                <a:rPr lang="en-US" dirty="0"/>
+                <a:t>Read-Only</a:t>
+              </a:r>
+            </a:p>
+          </p:txBody>
+        </p:sp>
+      </p:grpSp>
+      <p:grpSp>
+        <p:nvGrpSpPr>
+          <p:cNvPr id="21" name="Group 20">
+            <a:extLst>
+              <a:ext uri="{FF2B5EF4-FFF2-40B4-BE49-F238E27FC236}">
+                <a16:creationId xmlns:a16="http://schemas.microsoft.com/office/drawing/2014/main" id="{F2B70644-8B6A-EDC7-AC13-02DF0784EB23}"/>
+              </a:ext>
+            </a:extLst>
+          </p:cNvPr>
+          <p:cNvGrpSpPr/>
+          <p:nvPr/>
+        </p:nvGrpSpPr>
+        <p:grpSpPr>
+          <a:xfrm>
+            <a:off x="2554934" y="3355976"/>
+            <a:ext cx="7316038" cy="700769"/>
+            <a:chOff x="2628678" y="3863084"/>
+            <a:chExt cx="7316038" cy="700769"/>
+          </a:xfrm>
+        </p:grpSpPr>
+        <p:cxnSp>
+          <p:nvCxnSpPr>
+            <p:cNvPr id="16" name="Straight Arrow Connector 15">
+              <a:extLst>
+                <a:ext uri="{FF2B5EF4-FFF2-40B4-BE49-F238E27FC236}">
+                  <a16:creationId xmlns:a16="http://schemas.microsoft.com/office/drawing/2014/main" id="{9977876B-5256-AC66-DD3C-ED727952C0CB}"/>
+                </a:ext>
+              </a:extLst>
+            </p:cNvPr>
+            <p:cNvCxnSpPr>
+              <a:cxnSpLocks/>
+            </p:cNvCxnSpPr>
+            <p:nvPr/>
+          </p:nvCxnSpPr>
+          <p:spPr>
+            <a:xfrm>
+              <a:off x="4157555" y="4121497"/>
+              <a:ext cx="4282738" cy="0"/>
+            </a:xfrm>
+            <a:prstGeom prst="straightConnector1">
+              <a:avLst/>
+            </a:prstGeom>
+            <a:ln w="19050">
+              <a:tailEnd type="triangle"/>
+            </a:ln>
+          </p:spPr>
+          <p:style>
+            <a:lnRef idx="1">
+              <a:schemeClr val="accent1"/>
+            </a:lnRef>
+            <a:fillRef idx="0">
+              <a:schemeClr val="accent1"/>
+            </a:fillRef>
+            <a:effectRef idx="0">
+              <a:schemeClr val="accent1"/>
+            </a:effectRef>
+            <a:fontRef idx="minor">
+              <a:schemeClr val="tx1"/>
+            </a:fontRef>
+          </p:style>
+        </p:cxnSp>
+        <p:sp>
+          <p:nvSpPr>
+            <p:cNvPr id="17" name="TextBox 16">
+              <a:extLst>
+                <a:ext uri="{FF2B5EF4-FFF2-40B4-BE49-F238E27FC236}">
+                  <a16:creationId xmlns:a16="http://schemas.microsoft.com/office/drawing/2014/main" id="{6C146770-D3EB-A36B-0624-A2798A9276EE}"/>
+                </a:ext>
+              </a:extLst>
+            </p:cNvPr>
+            <p:cNvSpPr txBox="1"/>
+            <p:nvPr/>
+          </p:nvSpPr>
+          <p:spPr>
+            <a:xfrm>
+              <a:off x="2628678" y="3863084"/>
+              <a:ext cx="1528877" cy="646331"/>
+            </a:xfrm>
+            <a:prstGeom prst="rect">
+              <a:avLst/>
+            </a:prstGeom>
+            <a:noFill/>
+          </p:spPr>
+          <p:txBody>
+            <a:bodyPr wrap="square" rtlCol="0">
+              <a:spAutoFit/>
+            </a:bodyPr>
+            <a:lstStyle/>
+            <a:p>
+              <a:pPr algn="ctr"/>
+              <a:r>
+                <a:rPr lang="en-US" dirty="0"/>
+                <a:t>Property Graphs</a:t>
+              </a:r>
+            </a:p>
+          </p:txBody>
+        </p:sp>
+        <p:sp>
+          <p:nvSpPr>
+            <p:cNvPr id="18" name="TextBox 17">
+              <a:extLst>
+                <a:ext uri="{FF2B5EF4-FFF2-40B4-BE49-F238E27FC236}">
+                  <a16:creationId xmlns:a16="http://schemas.microsoft.com/office/drawing/2014/main" id="{0E77557A-59D1-713A-6FAB-929526CCFE72}"/>
+                </a:ext>
+              </a:extLst>
+            </p:cNvPr>
+            <p:cNvSpPr txBox="1"/>
+            <p:nvPr/>
+          </p:nvSpPr>
+          <p:spPr>
+            <a:xfrm>
+              <a:off x="8181307" y="3917522"/>
+              <a:ext cx="1763409" cy="646331"/>
+            </a:xfrm>
+            <a:prstGeom prst="rect">
+              <a:avLst/>
+            </a:prstGeom>
+            <a:noFill/>
+          </p:spPr>
+          <p:txBody>
+            <a:bodyPr wrap="square" rtlCol="0">
+              <a:spAutoFit/>
+            </a:bodyPr>
+            <a:lstStyle/>
+            <a:p>
+              <a:pPr algn="ctr"/>
+              <a:r>
+                <a:rPr lang="en-US" dirty="0"/>
+                <a:t>Structural Graphs</a:t>
+              </a:r>
+            </a:p>
+          </p:txBody>
+        </p:sp>
+      </p:grpSp>
+      <p:sp>
+        <p:nvSpPr>
+          <p:cNvPr id="19" name="TextBox 18">
+            <a:extLst>
+              <a:ext uri="{FF2B5EF4-FFF2-40B4-BE49-F238E27FC236}">
+                <a16:creationId xmlns:a16="http://schemas.microsoft.com/office/drawing/2014/main" id="{81A9BBF4-0C09-EFB2-9CD6-0086C389E7AB}"/>
+              </a:ext>
+            </a:extLst>
+          </p:cNvPr>
+          <p:cNvSpPr txBox="1"/>
+          <p:nvPr/>
+        </p:nvSpPr>
+        <p:spPr>
+          <a:xfrm>
+            <a:off x="4240049" y="1497635"/>
+            <a:ext cx="1606530" cy="646331"/>
+          </a:xfrm>
+          <a:prstGeom prst="rect">
+            <a:avLst/>
+          </a:prstGeom>
+          <a:noFill/>
+        </p:spPr>
+        <p:txBody>
+          <a:bodyPr wrap="none" rtlCol="0">
+            <a:spAutoFit/>
+          </a:bodyPr>
+          <a:lstStyle/>
+          <a:p>
+            <a:pPr algn="r"/>
+            <a:r>
+              <a:rPr lang="en-US" dirty="0"/>
+              <a:t>Neighborhood</a:t>
+            </a:r>
+            <a:br>
+              <a:rPr lang="en-US" dirty="0"/>
+            </a:br>
+            <a:r>
+              <a:rPr lang="en-US" dirty="0"/>
+              <a:t>queries</a:t>
+            </a:r>
+          </a:p>
+        </p:txBody>
+      </p:sp>
+      <p:sp>
+        <p:nvSpPr>
+          <p:cNvPr id="20" name="TextBox 19">
+            <a:extLst>
+              <a:ext uri="{FF2B5EF4-FFF2-40B4-BE49-F238E27FC236}">
+                <a16:creationId xmlns:a16="http://schemas.microsoft.com/office/drawing/2014/main" id="{58FB817C-727E-6319-7753-7D535569762E}"/>
+              </a:ext>
+            </a:extLst>
+          </p:cNvPr>
+          <p:cNvSpPr txBox="1"/>
+          <p:nvPr/>
+        </p:nvSpPr>
+        <p:spPr>
+          <a:xfrm>
+            <a:off x="6445768" y="1690904"/>
+            <a:ext cx="1071575" cy="369332"/>
+          </a:xfrm>
+          <a:prstGeom prst="rect">
+            <a:avLst/>
+          </a:prstGeom>
+          <a:noFill/>
+        </p:spPr>
+        <p:txBody>
+          <a:bodyPr wrap="none" rtlCol="0">
+            <a:spAutoFit/>
+          </a:bodyPr>
+          <a:lstStyle/>
+          <a:p>
+            <a:pPr algn="r"/>
+            <a:r>
+              <a:rPr lang="en-US" dirty="0"/>
+              <a:t>Traversal</a:t>
+            </a:r>
+          </a:p>
+        </p:txBody>
+      </p:sp>
+    </p:spTree>
+    <p:extLst>
+      <p:ext uri="{BB962C8B-B14F-4D97-AF65-F5344CB8AC3E}">
+        <p14:creationId xmlns:p14="http://schemas.microsoft.com/office/powerpoint/2010/main" val="803641172"/>
+      </p:ext>
+    </p:extLst>
+  </p:cSld>
+  <p:clrMapOvr>
+    <a:masterClrMapping/>
+  </p:clrMapOvr>
+</p:sld>
+</file>
+
 <file path=ppt/theme/theme1.xml><?xml version="1.0" encoding="utf-8"?>
 <a:theme xmlns:a="http://schemas.openxmlformats.org/drawingml/2006/main" name="Office Theme">
   <a:themeElements>

</xml_diff>